<commit_message>
Slides: 108 px cover titles in sd-06-004..008, PPTX re-exported
Co-Authored-By: Claude Opus 5.5 <noreply@anthropic.com>
Claude-Session: https://claude.ai/code/session_01C9pH8NnezrynRr5dznPeP3
</commit_message>
<xml_diff>
--- a/system-design-101/vi/lessons/sd-06-004/slides/sd-06-004.pptx
+++ b/system-design-101/vi/lessons/sd-06-004/slides/sd-06-004.pptx
@@ -1701,7 +1701,7 @@
         <p:spPr>
           <a:xfrm>
             <a:off x="914400" y="1428750"/>
-            <a:ext cx="16459200" cy="2505075"/>
+            <a:ext cx="16459200" cy="3600450"/>
           </a:xfrm>
           <a:prstGeom prst="rect">
             <a:avLst/>
@@ -1710,17 +1710,17 @@
           <a:ln/>
         </p:spPr>
         <p:txBody>
-          <a:bodyPr wrap="square" lIns="0" tIns="59563" rIns="0" bIns="-59563" rtlCol="0" anchor="t"/>
+          <a:bodyPr wrap="square" lIns="0" tIns="69437" rIns="0" bIns="-69437" rtlCol="0" anchor="t"/>
           <a:lstStyle/>
           <a:p>
             <a:pPr algn="l" indent="0" marL="0">
               <a:lnSpc>
-                <a:spcPts val="7298"/>
+                <a:spcPts val="8505"/>
               </a:lnSpc>
               <a:buNone/>
             </a:pPr>
             <a:r>
-              <a:rPr lang="en-US" sz="6950" dirty="0" spc="0" kern="0">
+              <a:rPr lang="en-US" sz="8100" dirty="0" spc="0" kern="0">
                 <a:solidFill>
                   <a:srgbClr val="F3EEE3"/>
                 </a:solidFill>
@@ -1731,7 +1731,7 @@
               <a:t>CDN</a:t>
             </a:r>
             <a:r>
-              <a:rPr lang="en-US" sz="6950" dirty="0" spc="1" kern="0">
+              <a:rPr lang="en-US" sz="8100" dirty="0" spc="1" kern="0">
                 <a:solidFill>
                   <a:srgbClr val="F3EEE3"/>
                 </a:solidFill>
@@ -1742,7 +1742,7 @@
               <a:t> cho</a:t>
             </a:r>
             <a:r>
-              <a:rPr lang="en-US" sz="6950" dirty="0" spc="-64" kern="0">
+              <a:rPr lang="en-US" sz="8100" dirty="0" spc="-79" kern="0">
                 <a:solidFill>
                   <a:srgbClr val="F3EEE3"/>
                 </a:solidFill>
@@ -1753,7 +1753,7 @@
               <a:t> người</a:t>
             </a:r>
             <a:r>
-              <a:rPr lang="en-US" sz="6950" dirty="0" spc="-25" kern="0">
+              <a:rPr lang="en-US" sz="8100" dirty="0" spc="-32" kern="0">
                 <a:solidFill>
                   <a:srgbClr val="F3EEE3"/>
                 </a:solidFill>
@@ -1764,7 +1764,7 @@
               <a:t> mới:</a:t>
             </a:r>
             <a:r>
-              <a:rPr lang="en-US" sz="6950" dirty="0" spc="1" kern="0">
+              <a:rPr lang="en-US" sz="8100" dirty="0" spc="1" kern="0">
                 <a:solidFill>
                   <a:srgbClr val="F3EEE3"/>
                 </a:solidFill>
@@ -1775,7 +1775,7 @@
               <a:t> máy</a:t>
             </a:r>
             <a:r>
-              <a:rPr lang="en-US" sz="6950" dirty="0" spc="-1" kern="0">
+              <a:rPr lang="en-US" sz="8100" dirty="0" spc="0" kern="0">
                 <a:solidFill>
                   <a:srgbClr val="F3EEE3"/>
                 </a:solidFill>
@@ -1786,7 +1786,7 @@
               <a:t> chủ</a:t>
             </a:r>
             <a:r>
-              <a:rPr lang="en-US" sz="6950" dirty="0" spc="3" kern="0">
+              <a:rPr lang="en-US" sz="8100" dirty="0" spc="2" kern="0">
                 <a:solidFill>
                   <a:srgbClr val="F3EEE3"/>
                 </a:solidFill>
@@ -1797,7 +1797,7 @@
               <a:t> biên,</a:t>
             </a:r>
             <a:r>
-              <a:rPr lang="en-US" sz="6950" dirty="0" spc="25" kern="0">
+              <a:rPr lang="en-US" sz="8100" dirty="0" spc="28" kern="0">
                 <a:solidFill>
                   <a:srgbClr val="F3EEE3"/>
                 </a:solidFill>
@@ -1808,7 +1808,7 @@
               <a:t> điện</a:t>
             </a:r>
             <a:r>
-              <a:rPr lang="en-US" sz="6950" dirty="0" spc="-32" kern="0">
+              <a:rPr lang="en-US" sz="8100" dirty="0" spc="-36" kern="0">
                 <a:solidFill>
                   <a:srgbClr val="F3EEE3"/>
                 </a:solidFill>
@@ -1819,7 +1819,7 @@
               <a:t> toán</a:t>
             </a:r>
             <a:r>
-              <a:rPr lang="en-US" sz="6950" dirty="0" spc="4" kern="0">
+              <a:rPr lang="en-US" sz="8100" dirty="0" spc="2" kern="0">
                 <a:solidFill>
                   <a:srgbClr val="F3EEE3"/>
                 </a:solidFill>
@@ -1830,7 +1830,7 @@
               <a:t> biên,</a:t>
             </a:r>
             <a:r>
-              <a:rPr lang="en-US" sz="6950" dirty="0" spc="-13" kern="0">
+              <a:rPr lang="en-US" sz="8100" dirty="0" spc="-16" kern="0">
                 <a:solidFill>
                   <a:srgbClr val="F3EEE3"/>
                 </a:solidFill>
@@ -1838,10 +1838,10 @@
                 <a:ea typeface="Bricolage Grotesque ExtraBold" pitchFamily="34" charset="-122"/>
                 <a:cs typeface="Bricolage Grotesque ExtraBold" pitchFamily="34" charset="-120"/>
               </a:rPr>
-              <a:t> game</a:t>
-            </a:r>
-            <a:r>
-              <a:rPr lang="en-US" sz="6950" dirty="0" spc="-14" kern="0">
+              <a:t> game trên</a:t>
+            </a:r>
+            <a:r>
+              <a:rPr lang="en-US" sz="8100" dirty="0" spc="0" kern="0">
                 <a:solidFill>
                   <a:srgbClr val="F3EEE3"/>
                 </a:solidFill>
@@ -1849,20 +1849,9 @@
                 <a:ea typeface="Bricolage Grotesque ExtraBold" pitchFamily="34" charset="-122"/>
                 <a:cs typeface="Bricolage Grotesque ExtraBold" pitchFamily="34" charset="-120"/>
               </a:rPr>
-              <a:t> trên</a:t>
-            </a:r>
-            <a:r>
-              <a:rPr lang="en-US" sz="6950" dirty="0" spc="-2" kern="0">
-                <a:solidFill>
-                  <a:srgbClr val="F3EEE3"/>
-                </a:solidFill>
-                <a:latin typeface="Bricolage Grotesque ExtraBold" pitchFamily="34" charset="0"/>
-                <a:ea typeface="Bricolage Grotesque ExtraBold" pitchFamily="34" charset="-122"/>
-                <a:cs typeface="Bricolage Grotesque ExtraBold" pitchFamily="34" charset="-120"/>
-              </a:rPr>
               <a:t> mây</a:t>
             </a:r>
-            <a:endParaRPr lang="en-US" sz="6950" dirty="0"/>
+            <a:endParaRPr lang="en-US" sz="8100" dirty="0"/>
           </a:p>
         </p:txBody>
       </p:sp>
@@ -1874,7 +1863,7 @@
         </p:nvSpPr>
         <p:spPr>
           <a:xfrm>
-            <a:off x="914400" y="4191000"/>
+            <a:off x="914400" y="5191125"/>
             <a:ext cx="16459200" cy="571500"/>
           </a:xfrm>
           <a:prstGeom prst="rect">
@@ -2001,12 +1990,12 @@
         </p:nvSpPr>
         <p:spPr>
           <a:xfrm>
-            <a:off x="914400" y="5524500"/>
-            <a:ext cx="5334000" cy="2667000"/>
+            <a:off x="914400" y="6286500"/>
+            <a:ext cx="5334000" cy="2381250"/>
           </a:xfrm>
           <a:prstGeom prst="roundRect">
             <a:avLst>
-              <a:gd name="adj" fmla="val 8571"/>
+              <a:gd name="adj" fmla="val 9600"/>
             </a:avLst>
           </a:prstGeom>
           <a:solidFill>
@@ -2028,7 +2017,7 @@
         </p:nvSpPr>
         <p:spPr>
           <a:xfrm>
-            <a:off x="1257300" y="5810250"/>
+            <a:off x="1257300" y="6524625"/>
             <a:ext cx="4648200" cy="762000"/>
           </a:xfrm>
           <a:prstGeom prst="rect">
@@ -2078,8 +2067,8 @@
         </p:nvSpPr>
         <p:spPr>
           <a:xfrm>
-            <a:off x="1257300" y="6762750"/>
-            <a:ext cx="4648200" cy="1143000"/>
+            <a:off x="1257300" y="7429500"/>
+            <a:ext cx="4648200" cy="1047750"/>
           </a:xfrm>
           <a:prstGeom prst="rect">
             <a:avLst/>
@@ -2164,12 +2153,12 @@
         </p:nvSpPr>
         <p:spPr>
           <a:xfrm>
-            <a:off x="6553200" y="5524500"/>
-            <a:ext cx="5334000" cy="2667000"/>
+            <a:off x="6553200" y="6286500"/>
+            <a:ext cx="5334000" cy="2381250"/>
           </a:xfrm>
           <a:prstGeom prst="roundRect">
             <a:avLst>
-              <a:gd name="adj" fmla="val 8571"/>
+              <a:gd name="adj" fmla="val 9600"/>
             </a:avLst>
           </a:prstGeom>
           <a:solidFill>
@@ -2191,7 +2180,7 @@
         </p:nvSpPr>
         <p:spPr>
           <a:xfrm>
-            <a:off x="6896100" y="5810250"/>
+            <a:off x="6896100" y="6524625"/>
             <a:ext cx="4648200" cy="762000"/>
           </a:xfrm>
           <a:prstGeom prst="rect">
@@ -2252,8 +2241,8 @@
         </p:nvSpPr>
         <p:spPr>
           <a:xfrm>
-            <a:off x="6896100" y="6762750"/>
-            <a:ext cx="4648200" cy="1143000"/>
+            <a:off x="6896100" y="7429500"/>
+            <a:ext cx="4648200" cy="1047750"/>
           </a:xfrm>
           <a:prstGeom prst="rect">
             <a:avLst/>
@@ -2338,12 +2327,12 @@
         </p:nvSpPr>
         <p:spPr>
           <a:xfrm>
-            <a:off x="12192000" y="5524500"/>
-            <a:ext cx="5334000" cy="2667000"/>
+            <a:off x="12192000" y="6286500"/>
+            <a:ext cx="5334000" cy="2381250"/>
           </a:xfrm>
           <a:prstGeom prst="roundRect">
             <a:avLst>
-              <a:gd name="adj" fmla="val 8571"/>
+              <a:gd name="adj" fmla="val 9600"/>
             </a:avLst>
           </a:prstGeom>
           <a:solidFill>
@@ -2365,7 +2354,7 @@
         </p:nvSpPr>
         <p:spPr>
           <a:xfrm>
-            <a:off x="12534900" y="5810250"/>
+            <a:off x="12534900" y="6524625"/>
             <a:ext cx="4648200" cy="762000"/>
           </a:xfrm>
           <a:prstGeom prst="rect">
@@ -2382,7 +2371,7 @@
               <a:buNone/>
             </a:pPr>
             <a:r>
-              <a:rPr lang="en-US" sz="3385" dirty="0" spc="-12" kern="0">
+              <a:rPr lang="en-US" sz="3900" dirty="0" spc="2" kern="0">
                 <a:solidFill>
                   <a:srgbClr val="3DD6A0"/>
                 </a:solidFill>
@@ -2390,10 +2379,10 @@
                 <a:ea typeface="Bricolage Grotesque ExtraBold" pitchFamily="34" charset="-122"/>
                 <a:cs typeface="Bricolage Grotesque ExtraBold" pitchFamily="34" charset="-120"/>
               </a:rPr>
-              <a:t>Chơi</a:t>
-            </a:r>
-            <a:r>
-              <a:rPr lang="en-US" sz="3385" dirty="0" spc="-6" kern="0">
+              <a:t>Game</a:t>
+            </a:r>
+            <a:r>
+              <a:rPr lang="en-US" sz="3900" dirty="0" spc="-8" kern="0">
                 <a:solidFill>
                   <a:srgbClr val="3DD6A0"/>
                 </a:solidFill>
@@ -2401,10 +2390,10 @@
                 <a:ea typeface="Bricolage Grotesque ExtraBold" pitchFamily="34" charset="-122"/>
                 <a:cs typeface="Bricolage Grotesque ExtraBold" pitchFamily="34" charset="-120"/>
               </a:rPr>
-              <a:t> game trên</a:t>
-            </a:r>
-            <a:r>
-              <a:rPr lang="en-US" sz="3385" dirty="0" spc="0" kern="0">
+              <a:t> trên</a:t>
+            </a:r>
+            <a:r>
+              <a:rPr lang="en-US" sz="3900" dirty="0" spc="4" kern="0">
                 <a:solidFill>
                   <a:srgbClr val="3DD6A0"/>
                 </a:solidFill>
@@ -2414,7 +2403,7 @@
               </a:rPr>
               <a:t> mây</a:t>
             </a:r>
-            <a:endParaRPr lang="en-US" sz="3385" dirty="0"/>
+            <a:endParaRPr lang="en-US" sz="3900" dirty="0"/>
           </a:p>
         </p:txBody>
       </p:sp>
@@ -2426,8 +2415,8 @@
         </p:nvSpPr>
         <p:spPr>
           <a:xfrm>
-            <a:off x="12534900" y="6762750"/>
-            <a:ext cx="4648200" cy="1143000"/>
+            <a:off x="12534900" y="7429500"/>
+            <a:ext cx="4648200" cy="1047750"/>
           </a:xfrm>
           <a:prstGeom prst="rect">
             <a:avLst/>

</xml_diff>